<commit_message>
docs: slide 4 — caption ajustat la "din 24 · +1 Singleton"
15 pattern-uri GoF din 24 (23 GoF + Singleton via Laravel container).
Eliminate captiones secundare ("import jucarenia.md + seed",
"minim universitar: 10 pattern-uri") pentru claritate vizuală.
</commit_message>
<xml_diff>
--- a/proiect final/Chircu_Mihail_TI-235_Prezentare_proiect_de_an.pptx
+++ b/proiect final/Chircu_Mihail_TI-235_Prezentare_proiect_de_an.pptx
@@ -5162,7 +5162,7 @@
                 <a:ea typeface="Calibri" pitchFamily="34" charset="-122"/>
                 <a:cs typeface="Calibri" pitchFamily="34" charset="-120"/>
               </a:rPr>
-              <a:t>din 23 — selectate pentru domeniu</a:t>
+              <a:t>din 24  ·  +1 Singleton (Laravel)</a:t>
             </a:r>
             <a:endParaRPr lang="en-US" sz="1100" dirty="0"/>
           </a:p>
@@ -5396,7 +5396,7 @@
                 <a:ea typeface="Calibri" pitchFamily="34" charset="-122"/>
                 <a:cs typeface="Calibri" pitchFamily="34" charset="-120"/>
               </a:rPr>
-              <a:t>import jucarenia.md + seed</a:t>
+              <a:t/>
             </a:r>
             <a:endParaRPr lang="en-US" sz="1100" dirty="0"/>
           </a:p>
@@ -5513,7 +5513,7 @@
                 <a:ea typeface="Calibri" pitchFamily="34" charset="-122"/>
                 <a:cs typeface="Calibri" pitchFamily="34" charset="-120"/>
               </a:rPr>
-              <a:t>minim universitar: 10 pattern-uri</a:t>
+              <a:t/>
             </a:r>
             <a:endParaRPr lang="en-US" sz="1100" dirty="0"/>
           </a:p>

</xml_diff>

<commit_message>
docs: prezentare cu accent vibrant cherry red
Paletă schimbată din burgundy (#6D2E46) în cherry red (#E63946) —
mai aprins, mai vizibil în sală, păstrând tonul academic. Box-urile
cream din slide 8 (matricea Abstract Factory) și slide 9 trecute
pe roz pal (#FFE5E8) ca să armonizeze.

Eliminat din slide 9 callout-ul "Codul existent: neatins." — mesajul
e deja transmis de cele două coloane Push / DiscountValidation.
</commit_message>
<xml_diff>
--- a/proiect final/Chircu_Mihail_TI-235_Prezentare_proiect_de_an.pptx
+++ b/proiect final/Chircu_Mihail_TI-235_Prezentare_proiect_de_an.pptx
@@ -1869,7 +1869,7 @@
             <a:avLst/>
           </a:prstGeom>
           <a:solidFill>
-            <a:srgbClr val="6D2E46"/>
+            <a:srgbClr val="E63946"/>
           </a:solidFill>
           <a:ln/>
         </p:spPr>
@@ -2057,7 +2057,7 @@
             <a:r>
               <a:rPr lang="en-US" sz="2400" i="1" dirty="0">
                 <a:solidFill>
-                  <a:srgbClr val="6D2E46"/>
+                  <a:srgbClr val="E63946"/>
                 </a:solidFill>
                 <a:latin typeface="Georgia" pitchFamily="34" charset="0"/>
                 <a:ea typeface="Georgia" pitchFamily="34" charset="-122"/>
@@ -2084,7 +2084,7 @@
             <a:avLst/>
           </a:prstGeom>
           <a:solidFill>
-            <a:srgbClr val="6D2E46"/>
+            <a:srgbClr val="E63946"/>
           </a:solidFill>
           <a:ln/>
         </p:spPr>
@@ -2955,7 +2955,7 @@
             <a:r>
               <a:rPr lang="en-US" sz="5600" b="1" i="1" dirty="0">
                 <a:solidFill>
-                  <a:srgbClr val="6D2E46"/>
+                  <a:srgbClr val="E63946"/>
                 </a:solidFill>
                 <a:latin typeface="Georgia" pitchFamily="34" charset="0"/>
                 <a:ea typeface="Georgia" pitchFamily="34" charset="-122"/>
@@ -3072,7 +3072,7 @@
             <a:r>
               <a:rPr lang="en-US" sz="5600" b="1" i="1" dirty="0">
                 <a:solidFill>
-                  <a:srgbClr val="6D2E46"/>
+                  <a:srgbClr val="E63946"/>
                 </a:solidFill>
                 <a:latin typeface="Georgia" pitchFamily="34" charset="0"/>
                 <a:ea typeface="Georgia" pitchFamily="34" charset="-122"/>
@@ -3189,7 +3189,7 @@
             <a:r>
               <a:rPr lang="en-US" sz="5600" b="1" i="1" dirty="0">
                 <a:solidFill>
-                  <a:srgbClr val="6D2E46"/>
+                  <a:srgbClr val="E63946"/>
                 </a:solidFill>
                 <a:latin typeface="Georgia" pitchFamily="34" charset="0"/>
                 <a:ea typeface="Georgia" pitchFamily="34" charset="-122"/>
@@ -3404,7 +3404,7 @@
             <a:avLst/>
           </a:prstGeom>
           <a:solidFill>
-            <a:srgbClr val="6D2E46"/>
+            <a:srgbClr val="E63946"/>
           </a:solidFill>
           <a:ln/>
         </p:spPr>
@@ -3475,7 +3475,7 @@
             <a:r>
               <a:rPr lang="en-US" sz="3200" i="1" dirty="0">
                 <a:solidFill>
-                  <a:srgbClr val="6D2E46"/>
+                  <a:srgbClr val="E63946"/>
                 </a:solidFill>
                 <a:latin typeface="Georgia" pitchFamily="34" charset="0"/>
                 <a:ea typeface="Georgia" pitchFamily="34" charset="-122"/>
@@ -3781,7 +3781,7 @@
             <a:r>
               <a:rPr lang="en-US" sz="4000" b="1" i="1" dirty="0">
                 <a:solidFill>
-                  <a:srgbClr val="6D2E46"/>
+                  <a:srgbClr val="E63946"/>
                 </a:solidFill>
                 <a:latin typeface="Georgia" pitchFamily="34" charset="0"/>
                 <a:ea typeface="Georgia" pitchFamily="34" charset="-122"/>
@@ -3898,7 +3898,7 @@
             <a:r>
               <a:rPr lang="en-US" sz="1200" b="1" dirty="0">
                 <a:solidFill>
-                  <a:srgbClr val="6D2E46"/>
+                  <a:srgbClr val="E63946"/>
                 </a:solidFill>
                 <a:latin typeface="Calibri" pitchFamily="34" charset="0"/>
                 <a:ea typeface="Calibri" pitchFamily="34" charset="-122"/>
@@ -3937,7 +3937,7 @@
             <a:r>
               <a:rPr lang="en-US" sz="4000" b="1" i="1" dirty="0">
                 <a:solidFill>
-                  <a:srgbClr val="6D2E46"/>
+                  <a:srgbClr val="E63946"/>
                 </a:solidFill>
                 <a:latin typeface="Georgia" pitchFamily="34" charset="0"/>
                 <a:ea typeface="Georgia" pitchFamily="34" charset="-122"/>
@@ -4054,7 +4054,7 @@
             <a:r>
               <a:rPr lang="en-US" sz="1200" b="1" dirty="0">
                 <a:solidFill>
-                  <a:srgbClr val="6D2E46"/>
+                  <a:srgbClr val="E63946"/>
                 </a:solidFill>
                 <a:latin typeface="Calibri" pitchFamily="34" charset="0"/>
                 <a:ea typeface="Calibri" pitchFamily="34" charset="-122"/>
@@ -4093,7 +4093,7 @@
             <a:r>
               <a:rPr lang="en-US" sz="4000" b="1" i="1" dirty="0">
                 <a:solidFill>
-                  <a:srgbClr val="6D2E46"/>
+                  <a:srgbClr val="E63946"/>
                 </a:solidFill>
                 <a:latin typeface="Georgia" pitchFamily="34" charset="0"/>
                 <a:ea typeface="Georgia" pitchFamily="34" charset="-122"/>
@@ -4210,7 +4210,7 @@
             <a:r>
               <a:rPr lang="en-US" sz="1200" b="1" dirty="0">
                 <a:solidFill>
-                  <a:srgbClr val="6D2E46"/>
+                  <a:srgbClr val="E63946"/>
                 </a:solidFill>
                 <a:latin typeface="Calibri" pitchFamily="34" charset="0"/>
                 <a:ea typeface="Calibri" pitchFamily="34" charset="-122"/>
@@ -4499,7 +4499,7 @@
             <a:r>
               <a:rPr lang="en-US" sz="1000" b="1" dirty="0">
                 <a:solidFill>
-                  <a:srgbClr val="6D2E46"/>
+                  <a:srgbClr val="E63946"/>
                 </a:solidFill>
                 <a:latin typeface="Calibri" pitchFamily="34" charset="0"/>
                 <a:ea typeface="Calibri" pitchFamily="34" charset="-122"/>
@@ -4753,7 +4753,7 @@
             <a:r>
               <a:rPr lang="en-US" sz="1000" b="1" dirty="0">
                 <a:solidFill>
-                  <a:srgbClr val="6D2E46"/>
+                  <a:srgbClr val="E63946"/>
                 </a:solidFill>
                 <a:latin typeface="Calibri" pitchFamily="34" charset="0"/>
                 <a:ea typeface="Calibri" pitchFamily="34" charset="-122"/>
@@ -5078,7 +5078,7 @@
             <a:r>
               <a:rPr lang="en-US" sz="6400" b="1" dirty="0">
                 <a:solidFill>
-                  <a:srgbClr val="6D2E46"/>
+                  <a:srgbClr val="E63946"/>
                 </a:solidFill>
                 <a:latin typeface="Georgia" pitchFamily="34" charset="0"/>
                 <a:ea typeface="Georgia" pitchFamily="34" charset="-122"/>
@@ -5195,7 +5195,7 @@
             <a:r>
               <a:rPr lang="en-US" sz="6400" b="1" dirty="0">
                 <a:solidFill>
-                  <a:srgbClr val="6D2E46"/>
+                  <a:srgbClr val="E63946"/>
                 </a:solidFill>
                 <a:latin typeface="Georgia" pitchFamily="34" charset="0"/>
                 <a:ea typeface="Georgia" pitchFamily="34" charset="-122"/>
@@ -5312,7 +5312,7 @@
             <a:r>
               <a:rPr lang="en-US" sz="6400" b="1" dirty="0">
                 <a:solidFill>
-                  <a:srgbClr val="6D2E46"/>
+                  <a:srgbClr val="E63946"/>
                 </a:solidFill>
                 <a:latin typeface="Georgia" pitchFamily="34" charset="0"/>
                 <a:ea typeface="Georgia" pitchFamily="34" charset="-122"/>
@@ -5429,7 +5429,7 @@
             <a:r>
               <a:rPr lang="en-US" sz="6400" b="1" dirty="0">
                 <a:solidFill>
-                  <a:srgbClr val="6D2E46"/>
+                  <a:srgbClr val="E63946"/>
                 </a:solidFill>
                 <a:latin typeface="Georgia" pitchFamily="34" charset="0"/>
                 <a:ea typeface="Georgia" pitchFamily="34" charset="-122"/>
@@ -5832,7 +5832,7 @@
             <a:r>
               <a:rPr lang="en-US" sz="2200" i="1" dirty="0">
                 <a:solidFill>
-                  <a:srgbClr val="6D2E46"/>
+                  <a:srgbClr val="E63946"/>
                 </a:solidFill>
                 <a:latin typeface="Georgia" pitchFamily="34" charset="0"/>
                 <a:ea typeface="Georgia" pitchFamily="34" charset="-122"/>
@@ -5949,7 +5949,7 @@
             <a:r>
               <a:rPr lang="en-US" sz="1100" i="1" dirty="0">
                 <a:solidFill>
-                  <a:srgbClr val="6D2E46"/>
+                  <a:srgbClr val="E63946"/>
                 </a:solidFill>
                 <a:latin typeface="Calibri" pitchFamily="34" charset="0"/>
                 <a:ea typeface="Calibri" pitchFamily="34" charset="-122"/>
@@ -6008,7 +6008,7 @@
             <a:r>
               <a:rPr lang="en-US" sz="2200" i="1" dirty="0">
                 <a:solidFill>
-                  <a:srgbClr val="6D2E46"/>
+                  <a:srgbClr val="E63946"/>
                 </a:solidFill>
                 <a:latin typeface="Georgia" pitchFamily="34" charset="0"/>
                 <a:ea typeface="Georgia" pitchFamily="34" charset="-122"/>
@@ -6125,7 +6125,7 @@
             <a:r>
               <a:rPr lang="en-US" sz="1100" i="1" dirty="0">
                 <a:solidFill>
-                  <a:srgbClr val="6D2E46"/>
+                  <a:srgbClr val="E63946"/>
                 </a:solidFill>
                 <a:latin typeface="Calibri" pitchFamily="34" charset="0"/>
                 <a:ea typeface="Calibri" pitchFamily="34" charset="-122"/>
@@ -6184,7 +6184,7 @@
             <a:r>
               <a:rPr lang="en-US" sz="2200" i="1" dirty="0">
                 <a:solidFill>
-                  <a:srgbClr val="6D2E46"/>
+                  <a:srgbClr val="E63946"/>
                 </a:solidFill>
                 <a:latin typeface="Georgia" pitchFamily="34" charset="0"/>
                 <a:ea typeface="Georgia" pitchFamily="34" charset="-122"/>
@@ -6301,7 +6301,7 @@
             <a:r>
               <a:rPr lang="en-US" sz="1100" i="1" dirty="0">
                 <a:solidFill>
-                  <a:srgbClr val="6D2E46"/>
+                  <a:srgbClr val="E63946"/>
                 </a:solidFill>
                 <a:latin typeface="Calibri" pitchFamily="34" charset="0"/>
                 <a:ea typeface="Calibri" pitchFamily="34" charset="-122"/>
@@ -6360,7 +6360,7 @@
             <a:r>
               <a:rPr lang="en-US" sz="2200" i="1" dirty="0">
                 <a:solidFill>
-                  <a:srgbClr val="6D2E46"/>
+                  <a:srgbClr val="E63946"/>
                 </a:solidFill>
                 <a:latin typeface="Georgia" pitchFamily="34" charset="0"/>
                 <a:ea typeface="Georgia" pitchFamily="34" charset="-122"/>
@@ -6477,7 +6477,7 @@
             <a:r>
               <a:rPr lang="en-US" sz="1100" i="1" dirty="0">
                 <a:solidFill>
-                  <a:srgbClr val="6D2E46"/>
+                  <a:srgbClr val="E63946"/>
                 </a:solidFill>
                 <a:latin typeface="Calibri" pitchFamily="34" charset="0"/>
                 <a:ea typeface="Calibri" pitchFamily="34" charset="-122"/>
@@ -6763,7 +6763,7 @@
             <a:r>
               <a:rPr lang="en-US" sz="2200" i="1" dirty="0">
                 <a:solidFill>
-                  <a:srgbClr val="6D2E46"/>
+                  <a:srgbClr val="E63946"/>
                 </a:solidFill>
                 <a:latin typeface="Georgia" pitchFamily="34" charset="0"/>
                 <a:ea typeface="Georgia" pitchFamily="34" charset="-122"/>
@@ -6880,7 +6880,7 @@
             <a:r>
               <a:rPr lang="en-US" sz="1100" i="1" dirty="0">
                 <a:solidFill>
-                  <a:srgbClr val="6D2E46"/>
+                  <a:srgbClr val="E63946"/>
                 </a:solidFill>
                 <a:latin typeface="Calibri" pitchFamily="34" charset="0"/>
                 <a:ea typeface="Calibri" pitchFamily="34" charset="-122"/>
@@ -6939,7 +6939,7 @@
             <a:r>
               <a:rPr lang="en-US" sz="2200" i="1" dirty="0">
                 <a:solidFill>
-                  <a:srgbClr val="6D2E46"/>
+                  <a:srgbClr val="E63946"/>
                 </a:solidFill>
                 <a:latin typeface="Georgia" pitchFamily="34" charset="0"/>
                 <a:ea typeface="Georgia" pitchFamily="34" charset="-122"/>
@@ -7056,7 +7056,7 @@
             <a:r>
               <a:rPr lang="en-US" sz="1100" i="1" dirty="0">
                 <a:solidFill>
-                  <a:srgbClr val="6D2E46"/>
+                  <a:srgbClr val="E63946"/>
                 </a:solidFill>
                 <a:latin typeface="Calibri" pitchFamily="34" charset="0"/>
                 <a:ea typeface="Calibri" pitchFamily="34" charset="-122"/>
@@ -7115,7 +7115,7 @@
             <a:r>
               <a:rPr lang="en-US" sz="2200" i="1" dirty="0">
                 <a:solidFill>
-                  <a:srgbClr val="6D2E46"/>
+                  <a:srgbClr val="E63946"/>
                 </a:solidFill>
                 <a:latin typeface="Georgia" pitchFamily="34" charset="0"/>
                 <a:ea typeface="Georgia" pitchFamily="34" charset="-122"/>
@@ -7232,7 +7232,7 @@
             <a:r>
               <a:rPr lang="en-US" sz="1100" i="1" dirty="0">
                 <a:solidFill>
-                  <a:srgbClr val="6D2E46"/>
+                  <a:srgbClr val="E63946"/>
                 </a:solidFill>
                 <a:latin typeface="Calibri" pitchFamily="34" charset="0"/>
                 <a:ea typeface="Calibri" pitchFamily="34" charset="-122"/>
@@ -7291,7 +7291,7 @@
             <a:r>
               <a:rPr lang="en-US" sz="2200" i="1" dirty="0">
                 <a:solidFill>
-                  <a:srgbClr val="6D2E46"/>
+                  <a:srgbClr val="E63946"/>
                 </a:solidFill>
                 <a:latin typeface="Georgia" pitchFamily="34" charset="0"/>
                 <a:ea typeface="Georgia" pitchFamily="34" charset="-122"/>
@@ -7408,7 +7408,7 @@
             <a:r>
               <a:rPr lang="en-US" sz="1100" i="1" dirty="0">
                 <a:solidFill>
-                  <a:srgbClr val="6D2E46"/>
+                  <a:srgbClr val="E63946"/>
                 </a:solidFill>
                 <a:latin typeface="Calibri" pitchFamily="34" charset="0"/>
                 <a:ea typeface="Calibri" pitchFamily="34" charset="-122"/>
@@ -7467,7 +7467,7 @@
             <a:r>
               <a:rPr lang="en-US" sz="2200" i="1" dirty="0">
                 <a:solidFill>
-                  <a:srgbClr val="6D2E46"/>
+                  <a:srgbClr val="E63946"/>
                 </a:solidFill>
                 <a:latin typeface="Georgia" pitchFamily="34" charset="0"/>
                 <a:ea typeface="Georgia" pitchFamily="34" charset="-122"/>
@@ -7584,7 +7584,7 @@
             <a:r>
               <a:rPr lang="en-US" sz="1100" i="1" dirty="0">
                 <a:solidFill>
-                  <a:srgbClr val="6D2E46"/>
+                  <a:srgbClr val="E63946"/>
                 </a:solidFill>
                 <a:latin typeface="Calibri" pitchFamily="34" charset="0"/>
                 <a:ea typeface="Calibri" pitchFamily="34" charset="-122"/>
@@ -7870,7 +7870,7 @@
             <a:r>
               <a:rPr lang="en-US" sz="2200" i="1" dirty="0">
                 <a:solidFill>
-                  <a:srgbClr val="6D2E46"/>
+                  <a:srgbClr val="E63946"/>
                 </a:solidFill>
                 <a:latin typeface="Georgia" pitchFamily="34" charset="0"/>
                 <a:ea typeface="Georgia" pitchFamily="34" charset="-122"/>
@@ -7987,7 +7987,7 @@
             <a:r>
               <a:rPr lang="en-US" sz="1100" i="1" dirty="0">
                 <a:solidFill>
-                  <a:srgbClr val="6D2E46"/>
+                  <a:srgbClr val="E63946"/>
                 </a:solidFill>
                 <a:latin typeface="Calibri" pitchFamily="34" charset="0"/>
                 <a:ea typeface="Calibri" pitchFamily="34" charset="-122"/>
@@ -8046,7 +8046,7 @@
             <a:r>
               <a:rPr lang="en-US" sz="2200" i="1" dirty="0">
                 <a:solidFill>
-                  <a:srgbClr val="6D2E46"/>
+                  <a:srgbClr val="E63946"/>
                 </a:solidFill>
                 <a:latin typeface="Georgia" pitchFamily="34" charset="0"/>
                 <a:ea typeface="Georgia" pitchFamily="34" charset="-122"/>
@@ -8163,7 +8163,7 @@
             <a:r>
               <a:rPr lang="en-US" sz="1100" i="1" dirty="0">
                 <a:solidFill>
-                  <a:srgbClr val="6D2E46"/>
+                  <a:srgbClr val="E63946"/>
                 </a:solidFill>
                 <a:latin typeface="Calibri" pitchFamily="34" charset="0"/>
                 <a:ea typeface="Calibri" pitchFamily="34" charset="-122"/>
@@ -8222,7 +8222,7 @@
             <a:r>
               <a:rPr lang="en-US" sz="2200" i="1" dirty="0">
                 <a:solidFill>
-                  <a:srgbClr val="6D2E46"/>
+                  <a:srgbClr val="E63946"/>
                 </a:solidFill>
                 <a:latin typeface="Georgia" pitchFamily="34" charset="0"/>
                 <a:ea typeface="Georgia" pitchFamily="34" charset="-122"/>
@@ -8339,7 +8339,7 @@
             <a:r>
               <a:rPr lang="en-US" sz="1100" i="1" dirty="0">
                 <a:solidFill>
-                  <a:srgbClr val="6D2E46"/>
+                  <a:srgbClr val="E63946"/>
                 </a:solidFill>
                 <a:latin typeface="Calibri" pitchFamily="34" charset="0"/>
                 <a:ea typeface="Calibri" pitchFamily="34" charset="-122"/>
@@ -8398,7 +8398,7 @@
             <a:r>
               <a:rPr lang="en-US" sz="2200" i="1" dirty="0">
                 <a:solidFill>
-                  <a:srgbClr val="6D2E46"/>
+                  <a:srgbClr val="E63946"/>
                 </a:solidFill>
                 <a:latin typeface="Georgia" pitchFamily="34" charset="0"/>
                 <a:ea typeface="Georgia" pitchFamily="34" charset="-122"/>
@@ -8515,7 +8515,7 @@
             <a:r>
               <a:rPr lang="en-US" sz="1100" i="1" dirty="0">
                 <a:solidFill>
-                  <a:srgbClr val="6D2E46"/>
+                  <a:srgbClr val="E63946"/>
                 </a:solidFill>
                 <a:latin typeface="Calibri" pitchFamily="34" charset="0"/>
                 <a:ea typeface="Calibri" pitchFamily="34" charset="-122"/>
@@ -8574,7 +8574,7 @@
             <a:r>
               <a:rPr lang="en-US" sz="2200" i="1" dirty="0">
                 <a:solidFill>
-                  <a:srgbClr val="6D2E46"/>
+                  <a:srgbClr val="E63946"/>
                 </a:solidFill>
                 <a:latin typeface="Georgia" pitchFamily="34" charset="0"/>
                 <a:ea typeface="Georgia" pitchFamily="34" charset="-122"/>
@@ -8691,7 +8691,7 @@
             <a:r>
               <a:rPr lang="en-US" sz="1100" i="1" dirty="0">
                 <a:solidFill>
-                  <a:srgbClr val="6D2E46"/>
+                  <a:srgbClr val="E63946"/>
                 </a:solidFill>
                 <a:latin typeface="Calibri" pitchFamily="34" charset="0"/>
                 <a:ea typeface="Calibri" pitchFamily="34" charset="-122"/>
@@ -8750,7 +8750,7 @@
             <a:r>
               <a:rPr lang="en-US" sz="2200" i="1" dirty="0">
                 <a:solidFill>
-                  <a:srgbClr val="6D2E46"/>
+                  <a:srgbClr val="E63946"/>
                 </a:solidFill>
                 <a:latin typeface="Georgia" pitchFamily="34" charset="0"/>
                 <a:ea typeface="Georgia" pitchFamily="34" charset="-122"/>
@@ -8867,7 +8867,7 @@
             <a:r>
               <a:rPr lang="en-US" sz="1100" i="1" dirty="0">
                 <a:solidFill>
-                  <a:srgbClr val="6D2E46"/>
+                  <a:srgbClr val="E63946"/>
                 </a:solidFill>
                 <a:latin typeface="Calibri" pitchFamily="34" charset="0"/>
                 <a:ea typeface="Calibri" pitchFamily="34" charset="-122"/>
@@ -9153,7 +9153,7 @@
             <a:r>
               <a:rPr lang="en-US" sz="1000" b="1" dirty="0">
                 <a:solidFill>
-                  <a:srgbClr val="6D2E46"/>
+                  <a:srgbClr val="E63946"/>
                 </a:solidFill>
                 <a:latin typeface="Calibri" pitchFamily="34" charset="0"/>
                 <a:ea typeface="Calibri" pitchFamily="34" charset="-122"/>
@@ -9231,7 +9231,7 @@
             <a:r>
               <a:rPr lang="en-US" sz="1000" b="1" dirty="0">
                 <a:solidFill>
-                  <a:srgbClr val="6D2E46"/>
+                  <a:srgbClr val="E63946"/>
                 </a:solidFill>
                 <a:latin typeface="Calibri" pitchFamily="34" charset="0"/>
                 <a:ea typeface="Calibri" pitchFamily="34" charset="-122"/>
@@ -9337,7 +9337,7 @@
             <a:r>
               <a:rPr lang="en-US" sz="1100" b="1" dirty="0">
                 <a:solidFill>
-                  <a:srgbClr val="6D2E46"/>
+                  <a:srgbClr val="E63946"/>
                 </a:solidFill>
                 <a:latin typeface="Calibri" pitchFamily="34" charset="0"/>
                 <a:ea typeface="Calibri" pitchFamily="34" charset="-122"/>
@@ -9376,7 +9376,7 @@
             <a:r>
               <a:rPr lang="en-US" sz="1100" b="1" dirty="0">
                 <a:solidFill>
-                  <a:srgbClr val="6D2E46"/>
+                  <a:srgbClr val="E63946"/>
                 </a:solidFill>
                 <a:latin typeface="Calibri" pitchFamily="34" charset="0"/>
                 <a:ea typeface="Calibri" pitchFamily="34" charset="-122"/>
@@ -9415,7 +9415,7 @@
             <a:r>
               <a:rPr lang="en-US" sz="1100" b="1" dirty="0">
                 <a:solidFill>
-                  <a:srgbClr val="6D2E46"/>
+                  <a:srgbClr val="E63946"/>
                 </a:solidFill>
                 <a:latin typeface="Calibri" pitchFamily="34" charset="0"/>
                 <a:ea typeface="Calibri" pitchFamily="34" charset="-122"/>
@@ -9481,7 +9481,7 @@
             <a:avLst/>
           </a:prstGeom>
           <a:solidFill>
-            <a:srgbClr val="F7F1E8"/>
+            <a:srgbClr val="FFE5E8"/>
           </a:solidFill>
           <a:ln w="6350">
             <a:solidFill>
@@ -9518,7 +9518,7 @@
             <a:r>
               <a:rPr lang="en-US" sz="1800" b="1" dirty="0">
                 <a:solidFill>
-                  <a:srgbClr val="6D2E46"/>
+                  <a:srgbClr val="E63946"/>
                 </a:solidFill>
                 <a:latin typeface="Georgia" pitchFamily="34" charset="0"/>
                 <a:ea typeface="Georgia" pitchFamily="34" charset="-122"/>
@@ -9545,7 +9545,7 @@
             <a:avLst/>
           </a:prstGeom>
           <a:solidFill>
-            <a:srgbClr val="F7F1E8"/>
+            <a:srgbClr val="FFE5E8"/>
           </a:solidFill>
           <a:ln w="6350">
             <a:solidFill>
@@ -9582,7 +9582,7 @@
             <a:r>
               <a:rPr lang="en-US" sz="1800" b="1" dirty="0">
                 <a:solidFill>
-                  <a:srgbClr val="6D2E46"/>
+                  <a:srgbClr val="E63946"/>
                 </a:solidFill>
                 <a:latin typeface="Georgia" pitchFamily="34" charset="0"/>
                 <a:ea typeface="Georgia" pitchFamily="34" charset="-122"/>
@@ -9609,7 +9609,7 @@
             <a:avLst/>
           </a:prstGeom>
           <a:solidFill>
-            <a:srgbClr val="F7F1E8"/>
+            <a:srgbClr val="FFE5E8"/>
           </a:solidFill>
           <a:ln w="6350">
             <a:solidFill>
@@ -9646,7 +9646,7 @@
             <a:r>
               <a:rPr lang="en-US" sz="1800" b="1" dirty="0">
                 <a:solidFill>
-                  <a:srgbClr val="6D2E46"/>
+                  <a:srgbClr val="E63946"/>
                 </a:solidFill>
                 <a:latin typeface="Georgia" pitchFamily="34" charset="0"/>
                 <a:ea typeface="Georgia" pitchFamily="34" charset="-122"/>
@@ -9712,7 +9712,7 @@
             <a:avLst/>
           </a:prstGeom>
           <a:solidFill>
-            <a:srgbClr val="F7F1E8"/>
+            <a:srgbClr val="FFE5E8"/>
           </a:solidFill>
           <a:ln w="6350">
             <a:solidFill>
@@ -9749,7 +9749,7 @@
             <a:r>
               <a:rPr lang="en-US" sz="1800" b="1" dirty="0">
                 <a:solidFill>
-                  <a:srgbClr val="6D2E46"/>
+                  <a:srgbClr val="E63946"/>
                 </a:solidFill>
                 <a:latin typeface="Georgia" pitchFamily="34" charset="0"/>
                 <a:ea typeface="Georgia" pitchFamily="34" charset="-122"/>
@@ -9776,7 +9776,7 @@
             <a:avLst/>
           </a:prstGeom>
           <a:solidFill>
-            <a:srgbClr val="F7F1E8"/>
+            <a:srgbClr val="FFE5E8"/>
           </a:solidFill>
           <a:ln w="6350">
             <a:solidFill>
@@ -9813,7 +9813,7 @@
             <a:r>
               <a:rPr lang="en-US" sz="1800" b="1" dirty="0">
                 <a:solidFill>
-                  <a:srgbClr val="6D2E46"/>
+                  <a:srgbClr val="E63946"/>
                 </a:solidFill>
                 <a:latin typeface="Georgia" pitchFamily="34" charset="0"/>
                 <a:ea typeface="Georgia" pitchFamily="34" charset="-122"/>
@@ -9840,7 +9840,7 @@
             <a:avLst/>
           </a:prstGeom>
           <a:solidFill>
-            <a:srgbClr val="F7F1E8"/>
+            <a:srgbClr val="FFE5E8"/>
           </a:solidFill>
           <a:ln w="6350">
             <a:solidFill>
@@ -9877,7 +9877,7 @@
             <a:r>
               <a:rPr lang="en-US" sz="1800" b="1" dirty="0">
                 <a:solidFill>
-                  <a:srgbClr val="6D2E46"/>
+                  <a:srgbClr val="E63946"/>
                 </a:solidFill>
                 <a:latin typeface="Georgia" pitchFamily="34" charset="0"/>
                 <a:ea typeface="Georgia" pitchFamily="34" charset="-122"/>
@@ -9943,7 +9943,7 @@
             <a:avLst/>
           </a:prstGeom>
           <a:solidFill>
-            <a:srgbClr val="F7F1E8"/>
+            <a:srgbClr val="FFE5E8"/>
           </a:solidFill>
           <a:ln w="6350">
             <a:solidFill>
@@ -9980,7 +9980,7 @@
             <a:r>
               <a:rPr lang="en-US" sz="1800" b="1" dirty="0">
                 <a:solidFill>
-                  <a:srgbClr val="6D2E46"/>
+                  <a:srgbClr val="E63946"/>
                 </a:solidFill>
                 <a:latin typeface="Georgia" pitchFamily="34" charset="0"/>
                 <a:ea typeface="Georgia" pitchFamily="34" charset="-122"/>
@@ -10007,7 +10007,7 @@
             <a:avLst/>
           </a:prstGeom>
           <a:solidFill>
-            <a:srgbClr val="F7F1E8"/>
+            <a:srgbClr val="FFE5E8"/>
           </a:solidFill>
           <a:ln w="6350">
             <a:solidFill>
@@ -10044,7 +10044,7 @@
             <a:r>
               <a:rPr lang="en-US" sz="1800" b="1" dirty="0">
                 <a:solidFill>
-                  <a:srgbClr val="6D2E46"/>
+                  <a:srgbClr val="E63946"/>
                 </a:solidFill>
                 <a:latin typeface="Georgia" pitchFamily="34" charset="0"/>
                 <a:ea typeface="Georgia" pitchFamily="34" charset="-122"/>
@@ -10071,7 +10071,7 @@
             <a:avLst/>
           </a:prstGeom>
           <a:solidFill>
-            <a:srgbClr val="F7F1E8"/>
+            <a:srgbClr val="FFE5E8"/>
           </a:solidFill>
           <a:ln w="6350">
             <a:solidFill>
@@ -10108,7 +10108,7 @@
             <a:r>
               <a:rPr lang="en-US" sz="1800" b="1" dirty="0">
                 <a:solidFill>
-                  <a:srgbClr val="6D2E46"/>
+                  <a:srgbClr val="E63946"/>
                 </a:solidFill>
                 <a:latin typeface="Georgia" pitchFamily="34" charset="0"/>
                 <a:ea typeface="Georgia" pitchFamily="34" charset="-122"/>
@@ -10433,7 +10433,7 @@
             <a:r>
               <a:rPr lang="en-US" sz="1000" b="1" dirty="0">
                 <a:solidFill>
-                  <a:srgbClr val="6D2E46"/>
+                  <a:srgbClr val="E63946"/>
                 </a:solidFill>
                 <a:latin typeface="Calibri" pitchFamily="34" charset="0"/>
                 <a:ea typeface="Calibri" pitchFamily="34" charset="-122"/>
@@ -10577,7 +10577,7 @@
             <a:avLst/>
           </a:prstGeom>
           <a:solidFill>
-            <a:srgbClr val="F7F1E8"/>
+            <a:srgbClr val="FFE5E8"/>
           </a:solidFill>
           <a:ln/>
         </p:spPr>
@@ -10648,7 +10648,7 @@
             <a:r>
               <a:rPr lang="en-US" sz="1000" b="1" dirty="0">
                 <a:solidFill>
-                  <a:srgbClr val="6D2E46"/>
+                  <a:srgbClr val="E63946"/>
                 </a:solidFill>
                 <a:latin typeface="Calibri" pitchFamily="34" charset="0"/>
                 <a:ea typeface="Calibri" pitchFamily="34" charset="-122"/>
@@ -10792,7 +10792,7 @@
             <a:avLst/>
           </a:prstGeom>
           <a:solidFill>
-            <a:srgbClr val="F7F1E8"/>
+            <a:srgbClr val="FFE5E8"/>
           </a:solidFill>
           <a:ln/>
         </p:spPr>
@@ -10833,45 +10833,6 @@
               <a:t>DiscountValidationHandler + 1 linie în pipeline</a:t>
             </a:r>
             <a:endParaRPr lang="en-US" sz="1100" dirty="0"/>
-          </a:p>
-        </p:txBody>
-      </p:sp>
-      <p:sp>
-        <p:nvSpPr>
-          <p:cNvPr id="18" name="Text 16"/>
-          <p:cNvSpPr/>
-          <p:nvPr/>
-        </p:nvSpPr>
-        <p:spPr>
-          <a:xfrm>
-            <a:off x="640080" y="5852160"/>
-            <a:ext cx="10908792" cy="457200"/>
-          </a:xfrm>
-          <a:prstGeom prst="rect">
-            <a:avLst/>
-          </a:prstGeom>
-          <a:noFill/>
-          <a:ln/>
-        </p:spPr>
-        <p:txBody>
-          <a:bodyPr wrap="square" lIns="0" tIns="0" rIns="0" bIns="0" rtlCol="0" anchor="ctr"/>
-          <a:lstStyle/>
-          <a:p>
-            <a:pPr algn="ctr" indent="0" marL="0">
-              <a:buNone/>
-            </a:pPr>
-            <a:r>
-              <a:rPr lang="en-US" sz="1600" i="1" dirty="0">
-                <a:solidFill>
-                  <a:srgbClr val="6D2E46"/>
-                </a:solidFill>
-                <a:latin typeface="Georgia" pitchFamily="34" charset="0"/>
-                <a:ea typeface="Georgia" pitchFamily="34" charset="-122"/>
-                <a:cs typeface="Georgia" pitchFamily="34" charset="-120"/>
-              </a:rPr>
-              <a:t>Codul existent: neatins.</a:t>
-            </a:r>
-            <a:endParaRPr lang="en-US" sz="1600" dirty="0"/>
           </a:p>
         </p:txBody>
       </p:sp>

</xml_diff>